<commit_message>
Extract the write-up text and add Word builds of both documents
</commit_message>
<xml_diff>
--- a/deck/custody-deck.pptx
+++ b/deck/custody-deck.pptx
@@ -778,7 +778,7 @@
           <a:p>
             <a:r>
               <a:rPr lang="en-US" dirty="0"/>
-              <a:t>Deliver this confidently, not apologetically.</a:t>
+              <a:t>Deliver this confidently, not apologetically. If pressed on the last row: the events table is append only and witnesses the fingerprint, so editing one record is reported. Defeating it means dropping the trigger and rewriting every table.</a:t>
             </a:r>
             <a:endParaRPr lang="en-US" dirty="0"/>
           </a:p>
@@ -1306,7 +1306,7 @@
           <a:p>
             <a:r>
               <a:rPr lang="en-US" dirty="0"/>
-              <a:t>Twenty seconds. Do not walk through every box.</a:t>
+              <a:t>Twenty seconds. Do not walk through every box. The same code runs on a laptop or hosted; the dashboard on show is the hosted one.</a:t>
             </a:r>
             <a:endParaRPr lang="en-US" dirty="0"/>
           </a:p>
@@ -3694,7 +3694,7 @@
                 <a:ea typeface="Times New Roman" pitchFamily="34" charset="-122"/>
                 <a:cs typeface="Times New Roman" pitchFamily="34" charset="-120"/>
               </a:rPr>
-              <a:t>full server access could rebuild the chain</a:t>
+              <a:t>single edits are caught, a full rewrite is not</a:t>
             </a:r>
             <a:endParaRPr lang="en-US" sz="1700" dirty="0"/>
           </a:p>
@@ -6347,7 +6347,7 @@
                 <a:ea typeface="Times New Roman" pitchFamily="34" charset="-122"/>
                 <a:cs typeface="Times New Roman" pitchFamily="34" charset="-120"/>
               </a:rPr>
-              <a:t>One laptop. No cloud. Nothing paid for. Works with the network down.</a:t>
+              <a:t>One laptop, or hosted. Nothing paid for. Works with the network down.</a:t>
             </a:r>
             <a:endParaRPr lang="en-US" sz="2000" dirty="0"/>
           </a:p>

</xml_diff>

<commit_message>
Drop the unfilled user-testing slide from the deck
</commit_message>
<xml_diff>
--- a/deck/custody-deck.pptx
+++ b/deck/custody-deck.pptx
@@ -17,10 +17,9 @@
     <p:sldId id="265" r:id="rId11"/>
     <p:sldId id="266" r:id="rId12"/>
     <p:sldId id="267" r:id="rId13"/>
-    <p:sldId id="268" r:id="rId14"/>
   </p:sldIdLst>
   <p:notesMasterIdLst>
-    <p:notesMasterId r:id="rId15"/>
+    <p:notesMasterId r:id="rId14"/>
   </p:notesMasterIdLst>
   <p:sldSz cx="9144000" cy="5143500"/>
   <p:notesSz cx="5143500" cy="9144000"/>
@@ -690,7 +689,7 @@
           <a:p>
             <a:r>
               <a:rPr lang="en-US" dirty="0"/>
-              <a:t>Complete this with the real result before presenting. An accurate account of what a reader did not understand is the only version worth reporting.</a:t>
+              <a:t>Deliver this confidently, not apologetically. If pressed on the last row: the events table is append only and witnesses the fingerprint, so editing one record is reported. Defeating it means dropping the trigger and rewriting every table.</a:t>
             </a:r>
             <a:endParaRPr lang="en-US" dirty="0"/>
           </a:p>
@@ -778,7 +777,7 @@
           <a:p>
             <a:r>
               <a:rPr lang="en-US" dirty="0"/>
-              <a:t>Deliver this confidently, not apologetically. If pressed on the last row: the events table is append only and witnesses the fingerprint, so editing one record is reported. Defeating it means dropping the trigger and rewriting every table.</a:t>
+              <a:t>One sentence, then stop.</a:t>
             </a:r>
             <a:endParaRPr lang="en-US" dirty="0"/>
           </a:p>
@@ -802,94 +801,6 @@
             <a:fld id="{F7021451-1387-4CA6-816F-3879F97B5CBC}" type="slidenum">
               <a:rPr lang="en-US"/>
               <a:t>12</a:t>
-            </a:fld>
-            <a:endParaRPr lang="en-US"/>
-          </a:p>
-        </p:txBody>
-      </p:sp>
-    </p:spTree>
-    <p:extLst>
-      <p:ext uri="{BB962C8B-B14F-4D97-AF65-F5344CB8AC3E}">
-        <p14:creationId xmlns:p14="http://schemas.microsoft.com/office/powerpoint/2010/main" val="1024086991"/>
-      </p:ext>
-    </p:extLst>
-  </p:cSld>
-  <p:clrMapOvr>
-    <a:masterClrMapping/>
-  </p:clrMapOvr>
-</p:notes>
-</file>
-
-<file path=ppt/notesSlides/notesSlide13.xml><?xml version="1.0" encoding="utf-8"?>
-<p:notes xmlns:a="http://schemas.openxmlformats.org/drawingml/2006/main" xmlns:r="http://schemas.openxmlformats.org/officeDocument/2006/relationships" xmlns:p="http://schemas.openxmlformats.org/presentationml/2006/main">
-  <p:cSld>
-    <p:spTree>
-      <p:nvGrpSpPr>
-        <p:cNvPr id="1" name=""/>
-        <p:cNvGrpSpPr/>
-        <p:nvPr/>
-      </p:nvGrpSpPr>
-      <p:grpSpPr>
-        <a:xfrm>
-          <a:off x="0" y="0"/>
-          <a:ext cx="0" cy="0"/>
-          <a:chOff x="0" y="0"/>
-          <a:chExt cx="0" cy="0"/>
-        </a:xfrm>
-      </p:grpSpPr>
-      <p:sp>
-        <p:nvSpPr>
-          <p:cNvPr id="2" name="Slide Image Placeholder 1"/>
-          <p:cNvSpPr>
-            <a:spLocks noGrp="1" noRot="1" noChangeAspect="1"/>
-          </p:cNvSpPr>
-          <p:nvPr>
-            <p:ph type="sldImg"/>
-          </p:nvPr>
-        </p:nvSpPr>
-        <p:spPr/>
-      </p:sp>
-      <p:sp>
-        <p:nvSpPr>
-          <p:cNvPr id="3" name="Notes Placeholder 2"/>
-          <p:cNvSpPr>
-            <a:spLocks noGrp="1"/>
-          </p:cNvSpPr>
-          <p:nvPr>
-            <p:ph type="body" idx="1"/>
-          </p:nvPr>
-        </p:nvSpPr>
-        <p:spPr/>
-        <p:txBody>
-          <a:bodyPr/>
-          <a:lstStyle/>
-          <a:p>
-            <a:r>
-              <a:rPr lang="en-US" dirty="0"/>
-              <a:t>One sentence, then stop.</a:t>
-            </a:r>
-            <a:endParaRPr lang="en-US" dirty="0"/>
-          </a:p>
-        </p:txBody>
-      </p:sp>
-      <p:sp>
-        <p:nvSpPr>
-          <p:cNvPr id="4" name="Slide Number Placeholder 3"/>
-          <p:cNvSpPr>
-            <a:spLocks noGrp="1"/>
-          </p:cNvSpPr>
-          <p:nvPr>
-            <p:ph type="sldNum" sz="quarter" idx="10"/>
-          </p:nvPr>
-        </p:nvSpPr>
-        <p:spPr/>
-        <p:txBody>
-          <a:bodyPr/>
-          <a:lstStyle/>
-          <a:p>
-            <a:fld id="{F7021451-1387-4CA6-816F-3879F97B5CBC}" type="slidenum">
-              <a:rPr lang="en-US"/>
-              <a:t>13</a:t>
             </a:fld>
             <a:endParaRPr lang="en-US"/>
           </a:p>
@@ -2804,7 +2715,7 @@
                 <a:ea typeface="Times New Roman" pitchFamily="34" charset="-122"/>
                 <a:cs typeface="Times New Roman" pitchFamily="34" charset="-120"/>
               </a:rPr>
-              <a:t>We tested it on people</a:t>
+              <a:t>What we did not solve</a:t>
             </a:r>
             <a:endParaRPr lang="en-US" sz="1150" dirty="0"/>
           </a:p>
@@ -2857,7 +2768,7 @@
         </p:nvSpPr>
         <p:spPr>
           <a:xfrm>
-            <a:off x="800100" y="1876425"/>
+            <a:off x="800100" y="1519238"/>
             <a:ext cx="7543800" cy="578644"/>
           </a:xfrm>
           <a:prstGeom prst="rect">
@@ -2882,7 +2793,7 @@
                 <a:ea typeface="Times New Roman" pitchFamily="34" charset="-122"/>
                 <a:cs typeface="Times New Roman" pitchFamily="34" charset="-120"/>
               </a:rPr>
-              <a:t>We gave the report to someone</a:t>
+              <a:t>Honest limits</a:t>
             </a:r>
             <a:endParaRPr lang="en-US" sz="3600" dirty="0"/>
           </a:p>
@@ -2896,24 +2807,24 @@
         </p:nvSpPr>
         <p:spPr>
           <a:xfrm>
-            <a:off x="800100" y="2305050"/>
-            <a:ext cx="7543800" cy="578644"/>
-          </a:xfrm>
-          <a:prstGeom prst="rect">
-            <a:avLst/>
-          </a:prstGeom>
-          <a:noFill/>
-          <a:ln/>
-        </p:spPr>
-        <p:txBody>
-          <a:bodyPr wrap="square" lIns="0" tIns="0" rIns="0" bIns="0" rtlCol="0" anchor="t"/>
-          <a:lstStyle/>
-          <a:p>
-            <a:pPr algn="l" indent="0" marL="0">
-              <a:buNone/>
-            </a:pPr>
-            <a:r>
-              <a:rPr lang="en-US" sz="3600" b="1" dirty="0">
+            <a:off x="800100" y="2233613"/>
+            <a:ext cx="2705100" cy="372904"/>
+          </a:xfrm>
+          <a:prstGeom prst="rect">
+            <a:avLst/>
+          </a:prstGeom>
+          <a:noFill/>
+          <a:ln/>
+        </p:spPr>
+        <p:txBody>
+          <a:bodyPr wrap="square" lIns="0" tIns="0" rIns="0" bIns="0" rtlCol="0" anchor="t"/>
+          <a:lstStyle/>
+          <a:p>
+            <a:pPr algn="l" indent="0" marL="0">
+              <a:buNone/>
+            </a:pPr>
+            <a:r>
+              <a:rPr lang="en-US" sz="1700" b="1" dirty="0">
                 <a:solidFill>
                   <a:srgbClr val="14140E"/>
                 </a:solidFill>
@@ -2921,9 +2832,9 @@
                 <a:ea typeface="Times New Roman" pitchFamily="34" charset="-122"/>
                 <a:cs typeface="Times New Roman" pitchFamily="34" charset="-120"/>
               </a:rPr>
-              <a:t>outside computer science.</a:t>
-            </a:r>
-            <a:endParaRPr lang="en-US" sz="3600" dirty="0"/>
+              <a:t>A corrupt collector</a:t>
+            </a:r>
+            <a:endParaRPr lang="en-US" sz="1700" dirty="0"/>
           </a:p>
         </p:txBody>
       </p:sp>
@@ -2935,24 +2846,63 @@
         </p:nvSpPr>
         <p:spPr>
           <a:xfrm>
-            <a:off x="800100" y="3019425"/>
-            <a:ext cx="3086100" cy="372904"/>
-          </a:xfrm>
-          <a:prstGeom prst="rect">
-            <a:avLst/>
-          </a:prstGeom>
-          <a:noFill/>
-          <a:ln/>
-        </p:spPr>
-        <p:txBody>
-          <a:bodyPr wrap="square" lIns="0" tIns="0" rIns="0" bIns="0" rtlCol="0" anchor="t"/>
-          <a:lstStyle/>
-          <a:p>
-            <a:pPr algn="l" indent="0" marL="0">
-              <a:buNone/>
-            </a:pPr>
-            <a:r>
-              <a:rPr lang="en-US" sz="2000" b="1" dirty="0">
+            <a:off x="3657600" y="2252663"/>
+            <a:ext cx="4686300" cy="372904"/>
+          </a:xfrm>
+          <a:prstGeom prst="rect">
+            <a:avLst/>
+          </a:prstGeom>
+          <a:noFill/>
+          <a:ln/>
+        </p:spPr>
+        <p:txBody>
+          <a:bodyPr wrap="square" lIns="0" tIns="0" rIns="0" bIns="0" rtlCol="0" anchor="t"/>
+          <a:lstStyle/>
+          <a:p>
+            <a:pPr algn="l" indent="0" marL="0">
+              <a:buNone/>
+            </a:pPr>
+            <a:r>
+              <a:rPr lang="en-US" sz="1700" dirty="0">
+                <a:solidFill>
+                  <a:srgbClr val="6E6E63"/>
+                </a:solidFill>
+                <a:latin typeface="Times New Roman" pitchFamily="34" charset="0"/>
+                <a:ea typeface="Times New Roman" pitchFamily="34" charset="-122"/>
+                <a:cs typeface="Times New Roman" pitchFamily="34" charset="-120"/>
+              </a:rPr>
+              <a:t>protected from collection onward, not before it</a:t>
+            </a:r>
+            <a:endParaRPr lang="en-US" sz="1700" dirty="0"/>
+          </a:p>
+        </p:txBody>
+      </p:sp>
+      <p:sp>
+        <p:nvSpPr>
+          <p:cNvPr id="8" name="Text 5"/>
+          <p:cNvSpPr txBox="1"/>
+          <p:nvPr/>
+        </p:nvSpPr>
+        <p:spPr>
+          <a:xfrm>
+            <a:off x="800100" y="2557463"/>
+            <a:ext cx="2705100" cy="372904"/>
+          </a:xfrm>
+          <a:prstGeom prst="rect">
+            <a:avLst/>
+          </a:prstGeom>
+          <a:noFill/>
+          <a:ln/>
+        </p:spPr>
+        <p:txBody>
+          <a:bodyPr wrap="square" lIns="0" tIns="0" rIns="0" bIns="0" rtlCol="0" anchor="t"/>
+          <a:lstStyle/>
+          <a:p>
+            <a:pPr algn="l" indent="0" marL="0">
+              <a:buNone/>
+            </a:pPr>
+            <a:r>
+              <a:rPr lang="en-US" sz="1700" b="1" dirty="0">
                 <a:solidFill>
                   <a:srgbClr val="14140E"/>
                 </a:solidFill>
@@ -2960,22 +2910,22 @@
                 <a:ea typeface="Times New Roman" pitchFamily="34" charset="-122"/>
                 <a:cs typeface="Times New Roman" pitchFamily="34" charset="-120"/>
               </a:rPr>
-              <a:t>What confused them</a:t>
-            </a:r>
-            <a:endParaRPr lang="en-US" sz="2000" dirty="0"/>
-          </a:p>
-        </p:txBody>
-      </p:sp>
-      <p:sp>
-        <p:nvSpPr>
-          <p:cNvPr id="8" name="Text 5"/>
-          <p:cNvSpPr txBox="1"/>
-          <p:nvPr/>
-        </p:nvSpPr>
-        <p:spPr>
-          <a:xfrm>
-            <a:off x="4038600" y="3038475"/>
-            <a:ext cx="4305300" cy="372904"/>
+              <a:t>The device clock</a:t>
+            </a:r>
+            <a:endParaRPr lang="en-US" sz="1700" dirty="0"/>
+          </a:p>
+        </p:txBody>
+      </p:sp>
+      <p:sp>
+        <p:nvSpPr>
+          <p:cNvPr id="9" name="Text 6"/>
+          <p:cNvSpPr txBox="1"/>
+          <p:nvPr/>
+        </p:nvSpPr>
+        <p:spPr>
+          <a:xfrm>
+            <a:off x="3657600" y="2576513"/>
+            <a:ext cx="4686300" cy="372904"/>
           </a:xfrm>
           <a:prstGeom prst="rect">
             <a:avLst/>
@@ -2999,7 +2949,7 @@
                 <a:ea typeface="Times New Roman" pitchFamily="34" charset="-122"/>
                 <a:cs typeface="Times New Roman" pitchFamily="34" charset="-120"/>
               </a:rPr>
-              <a:t>[ to complete ]</a:t>
+              <a:t>both clocks shown, the phone's not vouched for</a:t>
             </a:r>
             <a:endParaRPr lang="en-US" sz="1700" dirty="0"/>
           </a:p>
@@ -3007,30 +2957,30 @@
       </p:sp>
       <p:sp>
         <p:nvSpPr>
-          <p:cNvPr id="9" name="Text 6"/>
-          <p:cNvSpPr txBox="1"/>
-          <p:nvPr/>
-        </p:nvSpPr>
-        <p:spPr>
-          <a:xfrm>
-            <a:off x="800100" y="3419475"/>
-            <a:ext cx="3086100" cy="372904"/>
-          </a:xfrm>
-          <a:prstGeom prst="rect">
-            <a:avLst/>
-          </a:prstGeom>
-          <a:noFill/>
-          <a:ln/>
-        </p:spPr>
-        <p:txBody>
-          <a:bodyPr wrap="square" lIns="0" tIns="0" rIns="0" bIns="0" rtlCol="0" anchor="t"/>
-          <a:lstStyle/>
-          <a:p>
-            <a:pPr algn="l" indent="0" marL="0">
-              <a:buNone/>
-            </a:pPr>
-            <a:r>
-              <a:rPr lang="en-US" sz="2000" b="1" dirty="0">
+          <p:cNvPr id="10" name="Text 7"/>
+          <p:cNvSpPr txBox="1"/>
+          <p:nvPr/>
+        </p:nvSpPr>
+        <p:spPr>
+          <a:xfrm>
+            <a:off x="800100" y="2881313"/>
+            <a:ext cx="2705100" cy="372904"/>
+          </a:xfrm>
+          <a:prstGeom prst="rect">
+            <a:avLst/>
+          </a:prstGeom>
+          <a:noFill/>
+          <a:ln/>
+        </p:spPr>
+        <p:txBody>
+          <a:bodyPr wrap="square" lIns="0" tIns="0" rIns="0" bIns="0" rtlCol="0" anchor="t"/>
+          <a:lstStyle/>
+          <a:p>
+            <a:pPr algn="l" indent="0" marL="0">
+              <a:buNone/>
+            </a:pPr>
+            <a:r>
+              <a:rPr lang="en-US" sz="1700" b="1" dirty="0">
                 <a:solidFill>
                   <a:srgbClr val="14140E"/>
                 </a:solidFill>
@@ -3038,22 +2988,22 @@
                 <a:ea typeface="Times New Roman" pitchFamily="34" charset="-122"/>
                 <a:cs typeface="Times New Roman" pitchFamily="34" charset="-120"/>
               </a:rPr>
-              <a:t>What we changed</a:t>
-            </a:r>
-            <a:endParaRPr lang="en-US" sz="2000" dirty="0"/>
-          </a:p>
-        </p:txBody>
-      </p:sp>
-      <p:sp>
-        <p:nvSpPr>
-          <p:cNvPr id="10" name="Text 7"/>
-          <p:cNvSpPr txBox="1"/>
-          <p:nvPr/>
-        </p:nvSpPr>
-        <p:spPr>
-          <a:xfrm>
-            <a:off x="4038600" y="3438525"/>
-            <a:ext cx="4305300" cy="372904"/>
+              <a:t>Scale</a:t>
+            </a:r>
+            <a:endParaRPr lang="en-US" sz="1700" dirty="0"/>
+          </a:p>
+        </p:txBody>
+      </p:sp>
+      <p:sp>
+        <p:nvSpPr>
+          <p:cNvPr id="11" name="Text 8"/>
+          <p:cNvSpPr txBox="1"/>
+          <p:nvPr/>
+        </p:nvSpPr>
+        <p:spPr>
+          <a:xfrm>
+            <a:off x="3657600" y="2900363"/>
+            <a:ext cx="4686300" cy="372904"/>
           </a:xfrm>
           <a:prstGeom prst="rect">
             <a:avLst/>
@@ -3077,7 +3027,241 @@
                 <a:ea typeface="Times New Roman" pitchFamily="34" charset="-122"/>
                 <a:cs typeface="Times New Roman" pitchFamily="34" charset="-120"/>
               </a:rPr>
-              <a:t>[ to complete ]</a:t>
+              <a:t>tested at 30MB, extrapolated, not a real extraction</a:t>
+            </a:r>
+            <a:endParaRPr lang="en-US" sz="1700" dirty="0"/>
+          </a:p>
+        </p:txBody>
+      </p:sp>
+      <p:sp>
+        <p:nvSpPr>
+          <p:cNvPr id="12" name="Text 9"/>
+          <p:cNvSpPr txBox="1"/>
+          <p:nvPr/>
+        </p:nvSpPr>
+        <p:spPr>
+          <a:xfrm>
+            <a:off x="800100" y="3205163"/>
+            <a:ext cx="2705100" cy="372904"/>
+          </a:xfrm>
+          <a:prstGeom prst="rect">
+            <a:avLst/>
+          </a:prstGeom>
+          <a:noFill/>
+          <a:ln/>
+        </p:spPr>
+        <p:txBody>
+          <a:bodyPr wrap="square" lIns="0" tIns="0" rIns="0" bIns="0" rtlCol="0" anchor="t"/>
+          <a:lstStyle/>
+          <a:p>
+            <a:pPr algn="l" indent="0" marL="0">
+              <a:buNone/>
+            </a:pPr>
+            <a:r>
+              <a:rPr lang="en-US" sz="1700" b="1" dirty="0">
+                <a:solidFill>
+                  <a:srgbClr val="14140E"/>
+                </a:solidFill>
+                <a:latin typeface="Times New Roman" pitchFamily="34" charset="0"/>
+                <a:ea typeface="Times New Roman" pitchFamily="34" charset="-122"/>
+                <a:cs typeface="Times New Roman" pitchFamily="34" charset="-120"/>
+              </a:rPr>
+              <a:t>Per officer signing</a:t>
+            </a:r>
+            <a:endParaRPr lang="en-US" sz="1700" dirty="0"/>
+          </a:p>
+        </p:txBody>
+      </p:sp>
+      <p:sp>
+        <p:nvSpPr>
+          <p:cNvPr id="13" name="Text 10"/>
+          <p:cNvSpPr txBox="1"/>
+          <p:nvPr/>
+        </p:nvSpPr>
+        <p:spPr>
+          <a:xfrm>
+            <a:off x="3657600" y="3224213"/>
+            <a:ext cx="4686300" cy="372904"/>
+          </a:xfrm>
+          <a:prstGeom prst="rect">
+            <a:avLst/>
+          </a:prstGeom>
+          <a:noFill/>
+          <a:ln/>
+        </p:spPr>
+        <p:txBody>
+          <a:bodyPr wrap="square" lIns="0" tIns="0" rIns="0" bIns="0" rtlCol="0" anchor="t"/>
+          <a:lstStyle/>
+          <a:p>
+            <a:pPr algn="l" indent="0" marL="0">
+              <a:buNone/>
+            </a:pPr>
+            <a:r>
+              <a:rPr lang="en-US" sz="1700" dirty="0">
+                <a:solidFill>
+                  <a:srgbClr val="6E6E63"/>
+                </a:solidFill>
+                <a:latin typeface="Times New Roman" pitchFamily="34" charset="0"/>
+                <a:ea typeface="Times New Roman" pitchFamily="34" charset="-122"/>
+                <a:cs typeface="Times New Roman" pitchFamily="34" charset="-120"/>
+              </a:rPr>
+              <a:t>tied to a login, not to a person's key</a:t>
+            </a:r>
+            <a:endParaRPr lang="en-US" sz="1700" dirty="0"/>
+          </a:p>
+        </p:txBody>
+      </p:sp>
+      <p:sp>
+        <p:nvSpPr>
+          <p:cNvPr id="14" name="Text 11"/>
+          <p:cNvSpPr txBox="1"/>
+          <p:nvPr/>
+        </p:nvSpPr>
+        <p:spPr>
+          <a:xfrm>
+            <a:off x="800100" y="3529013"/>
+            <a:ext cx="2705100" cy="372904"/>
+          </a:xfrm>
+          <a:prstGeom prst="rect">
+            <a:avLst/>
+          </a:prstGeom>
+          <a:noFill/>
+          <a:ln/>
+        </p:spPr>
+        <p:txBody>
+          <a:bodyPr wrap="square" lIns="0" tIns="0" rIns="0" bIns="0" rtlCol="0" anchor="t"/>
+          <a:lstStyle/>
+          <a:p>
+            <a:pPr algn="l" indent="0" marL="0">
+              <a:buNone/>
+            </a:pPr>
+            <a:r>
+              <a:rPr lang="en-US" sz="1700" b="1" dirty="0">
+                <a:solidFill>
+                  <a:srgbClr val="14140E"/>
+                </a:solidFill>
+                <a:latin typeface="Times New Roman" pitchFamily="34" charset="0"/>
+                <a:ea typeface="Times New Roman" pitchFamily="34" charset="-122"/>
+                <a:cs typeface="Times New Roman" pitchFamily="34" charset="-120"/>
+              </a:rPr>
+              <a:t>Storage</a:t>
+            </a:r>
+            <a:endParaRPr lang="en-US" sz="1700" dirty="0"/>
+          </a:p>
+        </p:txBody>
+      </p:sp>
+      <p:sp>
+        <p:nvSpPr>
+          <p:cNvPr id="15" name="Text 12"/>
+          <p:cNvSpPr txBox="1"/>
+          <p:nvPr/>
+        </p:nvSpPr>
+        <p:spPr>
+          <a:xfrm>
+            <a:off x="3657600" y="3548063"/>
+            <a:ext cx="4686300" cy="372904"/>
+          </a:xfrm>
+          <a:prstGeom prst="rect">
+            <a:avLst/>
+          </a:prstGeom>
+          <a:noFill/>
+          <a:ln/>
+        </p:spPr>
+        <p:txBody>
+          <a:bodyPr wrap="square" lIns="0" tIns="0" rIns="0" bIns="0" rtlCol="0" anchor="t"/>
+          <a:lstStyle/>
+          <a:p>
+            <a:pPr algn="l" indent="0" marL="0">
+              <a:buNone/>
+            </a:pPr>
+            <a:r>
+              <a:rPr lang="en-US" sz="1700" dirty="0">
+                <a:solidFill>
+                  <a:srgbClr val="6E6E63"/>
+                </a:solidFill>
+                <a:latin typeface="Times New Roman" pitchFamily="34" charset="0"/>
+                <a:ea typeface="Times New Roman" pitchFamily="34" charset="-122"/>
+                <a:cs typeface="Times New Roman" pitchFamily="34" charset="-120"/>
+              </a:rPr>
+              <a:t>change is proven, deletion is not prevented</a:t>
+            </a:r>
+            <a:endParaRPr lang="en-US" sz="1700" dirty="0"/>
+          </a:p>
+        </p:txBody>
+      </p:sp>
+      <p:sp>
+        <p:nvSpPr>
+          <p:cNvPr id="16" name="Text 13"/>
+          <p:cNvSpPr txBox="1"/>
+          <p:nvPr/>
+        </p:nvSpPr>
+        <p:spPr>
+          <a:xfrm>
+            <a:off x="800100" y="3852863"/>
+            <a:ext cx="2705100" cy="372904"/>
+          </a:xfrm>
+          <a:prstGeom prst="rect">
+            <a:avLst/>
+          </a:prstGeom>
+          <a:noFill/>
+          <a:ln/>
+        </p:spPr>
+        <p:txBody>
+          <a:bodyPr wrap="square" lIns="0" tIns="0" rIns="0" bIns="0" rtlCol="0" anchor="t"/>
+          <a:lstStyle/>
+          <a:p>
+            <a:pPr algn="l" indent="0" marL="0">
+              <a:buNone/>
+            </a:pPr>
+            <a:r>
+              <a:rPr lang="en-US" sz="1700" b="1" dirty="0">
+                <a:solidFill>
+                  <a:srgbClr val="14140E"/>
+                </a:solidFill>
+                <a:latin typeface="Times New Roman" pitchFamily="34" charset="0"/>
+                <a:ea typeface="Times New Roman" pitchFamily="34" charset="-122"/>
+                <a:cs typeface="Times New Roman" pitchFamily="34" charset="-120"/>
+              </a:rPr>
+              <a:t>Bulk compromise</a:t>
+            </a:r>
+            <a:endParaRPr lang="en-US" sz="1700" dirty="0"/>
+          </a:p>
+        </p:txBody>
+      </p:sp>
+      <p:sp>
+        <p:nvSpPr>
+          <p:cNvPr id="17" name="Text 14"/>
+          <p:cNvSpPr txBox="1"/>
+          <p:nvPr/>
+        </p:nvSpPr>
+        <p:spPr>
+          <a:xfrm>
+            <a:off x="3657600" y="3871913"/>
+            <a:ext cx="4686300" cy="372904"/>
+          </a:xfrm>
+          <a:prstGeom prst="rect">
+            <a:avLst/>
+          </a:prstGeom>
+          <a:noFill/>
+          <a:ln/>
+        </p:spPr>
+        <p:txBody>
+          <a:bodyPr wrap="square" lIns="0" tIns="0" rIns="0" bIns="0" rtlCol="0" anchor="t"/>
+          <a:lstStyle/>
+          <a:p>
+            <a:pPr algn="l" indent="0" marL="0">
+              <a:buNone/>
+            </a:pPr>
+            <a:r>
+              <a:rPr lang="en-US" sz="1700" dirty="0">
+                <a:solidFill>
+                  <a:srgbClr val="6E6E63"/>
+                </a:solidFill>
+                <a:latin typeface="Times New Roman" pitchFamily="34" charset="0"/>
+                <a:ea typeface="Times New Roman" pitchFamily="34" charset="-122"/>
+                <a:cs typeface="Times New Roman" pitchFamily="34" charset="-120"/>
+              </a:rPr>
+              <a:t>single edits are caught, a full rewrite is not</a:t>
             </a:r>
             <a:endParaRPr lang="en-US" sz="1700" dirty="0"/>
           </a:p>
@@ -3148,7 +3332,7 @@
                 <a:ea typeface="Times New Roman" pitchFamily="34" charset="-122"/>
                 <a:cs typeface="Times New Roman" pitchFamily="34" charset="-120"/>
               </a:rPr>
-              <a:t>What we did not solve</a:t>
+              <a:t>If asked</a:t>
             </a:r>
             <a:endParaRPr lang="en-US" sz="1150" dirty="0"/>
           </a:p>
@@ -3188,623 +3372,6 @@
                 <a:cs typeface="Times New Roman" pitchFamily="34" charset="-120"/>
               </a:rPr>
               <a:t>12</a:t>
-            </a:r>
-            <a:endParaRPr lang="en-US" sz="1050" dirty="0"/>
-          </a:p>
-        </p:txBody>
-      </p:sp>
-      <p:sp>
-        <p:nvSpPr>
-          <p:cNvPr id="5" name="Text 2"/>
-          <p:cNvSpPr txBox="1"/>
-          <p:nvPr/>
-        </p:nvSpPr>
-        <p:spPr>
-          <a:xfrm>
-            <a:off x="800100" y="1519238"/>
-            <a:ext cx="7543800" cy="578644"/>
-          </a:xfrm>
-          <a:prstGeom prst="rect">
-            <a:avLst/>
-          </a:prstGeom>
-          <a:noFill/>
-          <a:ln/>
-        </p:spPr>
-        <p:txBody>
-          <a:bodyPr wrap="square" lIns="0" tIns="0" rIns="0" bIns="0" rtlCol="0" anchor="t"/>
-          <a:lstStyle/>
-          <a:p>
-            <a:pPr algn="l" indent="0" marL="0">
-              <a:buNone/>
-            </a:pPr>
-            <a:r>
-              <a:rPr lang="en-US" sz="3600" b="1" dirty="0">
-                <a:solidFill>
-                  <a:srgbClr val="14140E"/>
-                </a:solidFill>
-                <a:latin typeface="Times New Roman" pitchFamily="34" charset="0"/>
-                <a:ea typeface="Times New Roman" pitchFamily="34" charset="-122"/>
-                <a:cs typeface="Times New Roman" pitchFamily="34" charset="-120"/>
-              </a:rPr>
-              <a:t>Honest limits</a:t>
-            </a:r>
-            <a:endParaRPr lang="en-US" sz="3600" dirty="0"/>
-          </a:p>
-        </p:txBody>
-      </p:sp>
-      <p:sp>
-        <p:nvSpPr>
-          <p:cNvPr id="6" name="Text 3"/>
-          <p:cNvSpPr txBox="1"/>
-          <p:nvPr/>
-        </p:nvSpPr>
-        <p:spPr>
-          <a:xfrm>
-            <a:off x="800100" y="2233613"/>
-            <a:ext cx="2705100" cy="372904"/>
-          </a:xfrm>
-          <a:prstGeom prst="rect">
-            <a:avLst/>
-          </a:prstGeom>
-          <a:noFill/>
-          <a:ln/>
-        </p:spPr>
-        <p:txBody>
-          <a:bodyPr wrap="square" lIns="0" tIns="0" rIns="0" bIns="0" rtlCol="0" anchor="t"/>
-          <a:lstStyle/>
-          <a:p>
-            <a:pPr algn="l" indent="0" marL="0">
-              <a:buNone/>
-            </a:pPr>
-            <a:r>
-              <a:rPr lang="en-US" sz="1700" b="1" dirty="0">
-                <a:solidFill>
-                  <a:srgbClr val="14140E"/>
-                </a:solidFill>
-                <a:latin typeface="Times New Roman" pitchFamily="34" charset="0"/>
-                <a:ea typeface="Times New Roman" pitchFamily="34" charset="-122"/>
-                <a:cs typeface="Times New Roman" pitchFamily="34" charset="-120"/>
-              </a:rPr>
-              <a:t>A corrupt collector</a:t>
-            </a:r>
-            <a:endParaRPr lang="en-US" sz="1700" dirty="0"/>
-          </a:p>
-        </p:txBody>
-      </p:sp>
-      <p:sp>
-        <p:nvSpPr>
-          <p:cNvPr id="7" name="Text 4"/>
-          <p:cNvSpPr txBox="1"/>
-          <p:nvPr/>
-        </p:nvSpPr>
-        <p:spPr>
-          <a:xfrm>
-            <a:off x="3657600" y="2252663"/>
-            <a:ext cx="4686300" cy="372904"/>
-          </a:xfrm>
-          <a:prstGeom prst="rect">
-            <a:avLst/>
-          </a:prstGeom>
-          <a:noFill/>
-          <a:ln/>
-        </p:spPr>
-        <p:txBody>
-          <a:bodyPr wrap="square" lIns="0" tIns="0" rIns="0" bIns="0" rtlCol="0" anchor="t"/>
-          <a:lstStyle/>
-          <a:p>
-            <a:pPr algn="l" indent="0" marL="0">
-              <a:buNone/>
-            </a:pPr>
-            <a:r>
-              <a:rPr lang="en-US" sz="1700" dirty="0">
-                <a:solidFill>
-                  <a:srgbClr val="6E6E63"/>
-                </a:solidFill>
-                <a:latin typeface="Times New Roman" pitchFamily="34" charset="0"/>
-                <a:ea typeface="Times New Roman" pitchFamily="34" charset="-122"/>
-                <a:cs typeface="Times New Roman" pitchFamily="34" charset="-120"/>
-              </a:rPr>
-              <a:t>protected from collection onward, not before it</a:t>
-            </a:r>
-            <a:endParaRPr lang="en-US" sz="1700" dirty="0"/>
-          </a:p>
-        </p:txBody>
-      </p:sp>
-      <p:sp>
-        <p:nvSpPr>
-          <p:cNvPr id="8" name="Text 5"/>
-          <p:cNvSpPr txBox="1"/>
-          <p:nvPr/>
-        </p:nvSpPr>
-        <p:spPr>
-          <a:xfrm>
-            <a:off x="800100" y="2557463"/>
-            <a:ext cx="2705100" cy="372904"/>
-          </a:xfrm>
-          <a:prstGeom prst="rect">
-            <a:avLst/>
-          </a:prstGeom>
-          <a:noFill/>
-          <a:ln/>
-        </p:spPr>
-        <p:txBody>
-          <a:bodyPr wrap="square" lIns="0" tIns="0" rIns="0" bIns="0" rtlCol="0" anchor="t"/>
-          <a:lstStyle/>
-          <a:p>
-            <a:pPr algn="l" indent="0" marL="0">
-              <a:buNone/>
-            </a:pPr>
-            <a:r>
-              <a:rPr lang="en-US" sz="1700" b="1" dirty="0">
-                <a:solidFill>
-                  <a:srgbClr val="14140E"/>
-                </a:solidFill>
-                <a:latin typeface="Times New Roman" pitchFamily="34" charset="0"/>
-                <a:ea typeface="Times New Roman" pitchFamily="34" charset="-122"/>
-                <a:cs typeface="Times New Roman" pitchFamily="34" charset="-120"/>
-              </a:rPr>
-              <a:t>The device clock</a:t>
-            </a:r>
-            <a:endParaRPr lang="en-US" sz="1700" dirty="0"/>
-          </a:p>
-        </p:txBody>
-      </p:sp>
-      <p:sp>
-        <p:nvSpPr>
-          <p:cNvPr id="9" name="Text 6"/>
-          <p:cNvSpPr txBox="1"/>
-          <p:nvPr/>
-        </p:nvSpPr>
-        <p:spPr>
-          <a:xfrm>
-            <a:off x="3657600" y="2576513"/>
-            <a:ext cx="4686300" cy="372904"/>
-          </a:xfrm>
-          <a:prstGeom prst="rect">
-            <a:avLst/>
-          </a:prstGeom>
-          <a:noFill/>
-          <a:ln/>
-        </p:spPr>
-        <p:txBody>
-          <a:bodyPr wrap="square" lIns="0" tIns="0" rIns="0" bIns="0" rtlCol="0" anchor="t"/>
-          <a:lstStyle/>
-          <a:p>
-            <a:pPr algn="l" indent="0" marL="0">
-              <a:buNone/>
-            </a:pPr>
-            <a:r>
-              <a:rPr lang="en-US" sz="1700" dirty="0">
-                <a:solidFill>
-                  <a:srgbClr val="6E6E63"/>
-                </a:solidFill>
-                <a:latin typeface="Times New Roman" pitchFamily="34" charset="0"/>
-                <a:ea typeface="Times New Roman" pitchFamily="34" charset="-122"/>
-                <a:cs typeface="Times New Roman" pitchFamily="34" charset="-120"/>
-              </a:rPr>
-              <a:t>both clocks shown, the phone's not vouched for</a:t>
-            </a:r>
-            <a:endParaRPr lang="en-US" sz="1700" dirty="0"/>
-          </a:p>
-        </p:txBody>
-      </p:sp>
-      <p:sp>
-        <p:nvSpPr>
-          <p:cNvPr id="10" name="Text 7"/>
-          <p:cNvSpPr txBox="1"/>
-          <p:nvPr/>
-        </p:nvSpPr>
-        <p:spPr>
-          <a:xfrm>
-            <a:off x="800100" y="2881313"/>
-            <a:ext cx="2705100" cy="372904"/>
-          </a:xfrm>
-          <a:prstGeom prst="rect">
-            <a:avLst/>
-          </a:prstGeom>
-          <a:noFill/>
-          <a:ln/>
-        </p:spPr>
-        <p:txBody>
-          <a:bodyPr wrap="square" lIns="0" tIns="0" rIns="0" bIns="0" rtlCol="0" anchor="t"/>
-          <a:lstStyle/>
-          <a:p>
-            <a:pPr algn="l" indent="0" marL="0">
-              <a:buNone/>
-            </a:pPr>
-            <a:r>
-              <a:rPr lang="en-US" sz="1700" b="1" dirty="0">
-                <a:solidFill>
-                  <a:srgbClr val="14140E"/>
-                </a:solidFill>
-                <a:latin typeface="Times New Roman" pitchFamily="34" charset="0"/>
-                <a:ea typeface="Times New Roman" pitchFamily="34" charset="-122"/>
-                <a:cs typeface="Times New Roman" pitchFamily="34" charset="-120"/>
-              </a:rPr>
-              <a:t>Scale</a:t>
-            </a:r>
-            <a:endParaRPr lang="en-US" sz="1700" dirty="0"/>
-          </a:p>
-        </p:txBody>
-      </p:sp>
-      <p:sp>
-        <p:nvSpPr>
-          <p:cNvPr id="11" name="Text 8"/>
-          <p:cNvSpPr txBox="1"/>
-          <p:nvPr/>
-        </p:nvSpPr>
-        <p:spPr>
-          <a:xfrm>
-            <a:off x="3657600" y="2900363"/>
-            <a:ext cx="4686300" cy="372904"/>
-          </a:xfrm>
-          <a:prstGeom prst="rect">
-            <a:avLst/>
-          </a:prstGeom>
-          <a:noFill/>
-          <a:ln/>
-        </p:spPr>
-        <p:txBody>
-          <a:bodyPr wrap="square" lIns="0" tIns="0" rIns="0" bIns="0" rtlCol="0" anchor="t"/>
-          <a:lstStyle/>
-          <a:p>
-            <a:pPr algn="l" indent="0" marL="0">
-              <a:buNone/>
-            </a:pPr>
-            <a:r>
-              <a:rPr lang="en-US" sz="1700" dirty="0">
-                <a:solidFill>
-                  <a:srgbClr val="6E6E63"/>
-                </a:solidFill>
-                <a:latin typeface="Times New Roman" pitchFamily="34" charset="0"/>
-                <a:ea typeface="Times New Roman" pitchFamily="34" charset="-122"/>
-                <a:cs typeface="Times New Roman" pitchFamily="34" charset="-120"/>
-              </a:rPr>
-              <a:t>tested at 30MB, extrapolated, not a real extraction</a:t>
-            </a:r>
-            <a:endParaRPr lang="en-US" sz="1700" dirty="0"/>
-          </a:p>
-        </p:txBody>
-      </p:sp>
-      <p:sp>
-        <p:nvSpPr>
-          <p:cNvPr id="12" name="Text 9"/>
-          <p:cNvSpPr txBox="1"/>
-          <p:nvPr/>
-        </p:nvSpPr>
-        <p:spPr>
-          <a:xfrm>
-            <a:off x="800100" y="3205163"/>
-            <a:ext cx="2705100" cy="372904"/>
-          </a:xfrm>
-          <a:prstGeom prst="rect">
-            <a:avLst/>
-          </a:prstGeom>
-          <a:noFill/>
-          <a:ln/>
-        </p:spPr>
-        <p:txBody>
-          <a:bodyPr wrap="square" lIns="0" tIns="0" rIns="0" bIns="0" rtlCol="0" anchor="t"/>
-          <a:lstStyle/>
-          <a:p>
-            <a:pPr algn="l" indent="0" marL="0">
-              <a:buNone/>
-            </a:pPr>
-            <a:r>
-              <a:rPr lang="en-US" sz="1700" b="1" dirty="0">
-                <a:solidFill>
-                  <a:srgbClr val="14140E"/>
-                </a:solidFill>
-                <a:latin typeface="Times New Roman" pitchFamily="34" charset="0"/>
-                <a:ea typeface="Times New Roman" pitchFamily="34" charset="-122"/>
-                <a:cs typeface="Times New Roman" pitchFamily="34" charset="-120"/>
-              </a:rPr>
-              <a:t>Per officer signing</a:t>
-            </a:r>
-            <a:endParaRPr lang="en-US" sz="1700" dirty="0"/>
-          </a:p>
-        </p:txBody>
-      </p:sp>
-      <p:sp>
-        <p:nvSpPr>
-          <p:cNvPr id="13" name="Text 10"/>
-          <p:cNvSpPr txBox="1"/>
-          <p:nvPr/>
-        </p:nvSpPr>
-        <p:spPr>
-          <a:xfrm>
-            <a:off x="3657600" y="3224213"/>
-            <a:ext cx="4686300" cy="372904"/>
-          </a:xfrm>
-          <a:prstGeom prst="rect">
-            <a:avLst/>
-          </a:prstGeom>
-          <a:noFill/>
-          <a:ln/>
-        </p:spPr>
-        <p:txBody>
-          <a:bodyPr wrap="square" lIns="0" tIns="0" rIns="0" bIns="0" rtlCol="0" anchor="t"/>
-          <a:lstStyle/>
-          <a:p>
-            <a:pPr algn="l" indent="0" marL="0">
-              <a:buNone/>
-            </a:pPr>
-            <a:r>
-              <a:rPr lang="en-US" sz="1700" dirty="0">
-                <a:solidFill>
-                  <a:srgbClr val="6E6E63"/>
-                </a:solidFill>
-                <a:latin typeface="Times New Roman" pitchFamily="34" charset="0"/>
-                <a:ea typeface="Times New Roman" pitchFamily="34" charset="-122"/>
-                <a:cs typeface="Times New Roman" pitchFamily="34" charset="-120"/>
-              </a:rPr>
-              <a:t>tied to a login, not to a person's key</a:t>
-            </a:r>
-            <a:endParaRPr lang="en-US" sz="1700" dirty="0"/>
-          </a:p>
-        </p:txBody>
-      </p:sp>
-      <p:sp>
-        <p:nvSpPr>
-          <p:cNvPr id="14" name="Text 11"/>
-          <p:cNvSpPr txBox="1"/>
-          <p:nvPr/>
-        </p:nvSpPr>
-        <p:spPr>
-          <a:xfrm>
-            <a:off x="800100" y="3529013"/>
-            <a:ext cx="2705100" cy="372904"/>
-          </a:xfrm>
-          <a:prstGeom prst="rect">
-            <a:avLst/>
-          </a:prstGeom>
-          <a:noFill/>
-          <a:ln/>
-        </p:spPr>
-        <p:txBody>
-          <a:bodyPr wrap="square" lIns="0" tIns="0" rIns="0" bIns="0" rtlCol="0" anchor="t"/>
-          <a:lstStyle/>
-          <a:p>
-            <a:pPr algn="l" indent="0" marL="0">
-              <a:buNone/>
-            </a:pPr>
-            <a:r>
-              <a:rPr lang="en-US" sz="1700" b="1" dirty="0">
-                <a:solidFill>
-                  <a:srgbClr val="14140E"/>
-                </a:solidFill>
-                <a:latin typeface="Times New Roman" pitchFamily="34" charset="0"/>
-                <a:ea typeface="Times New Roman" pitchFamily="34" charset="-122"/>
-                <a:cs typeface="Times New Roman" pitchFamily="34" charset="-120"/>
-              </a:rPr>
-              <a:t>Storage</a:t>
-            </a:r>
-            <a:endParaRPr lang="en-US" sz="1700" dirty="0"/>
-          </a:p>
-        </p:txBody>
-      </p:sp>
-      <p:sp>
-        <p:nvSpPr>
-          <p:cNvPr id="15" name="Text 12"/>
-          <p:cNvSpPr txBox="1"/>
-          <p:nvPr/>
-        </p:nvSpPr>
-        <p:spPr>
-          <a:xfrm>
-            <a:off x="3657600" y="3548063"/>
-            <a:ext cx="4686300" cy="372904"/>
-          </a:xfrm>
-          <a:prstGeom prst="rect">
-            <a:avLst/>
-          </a:prstGeom>
-          <a:noFill/>
-          <a:ln/>
-        </p:spPr>
-        <p:txBody>
-          <a:bodyPr wrap="square" lIns="0" tIns="0" rIns="0" bIns="0" rtlCol="0" anchor="t"/>
-          <a:lstStyle/>
-          <a:p>
-            <a:pPr algn="l" indent="0" marL="0">
-              <a:buNone/>
-            </a:pPr>
-            <a:r>
-              <a:rPr lang="en-US" sz="1700" dirty="0">
-                <a:solidFill>
-                  <a:srgbClr val="6E6E63"/>
-                </a:solidFill>
-                <a:latin typeface="Times New Roman" pitchFamily="34" charset="0"/>
-                <a:ea typeface="Times New Roman" pitchFamily="34" charset="-122"/>
-                <a:cs typeface="Times New Roman" pitchFamily="34" charset="-120"/>
-              </a:rPr>
-              <a:t>change is proven, deletion is not prevented</a:t>
-            </a:r>
-            <a:endParaRPr lang="en-US" sz="1700" dirty="0"/>
-          </a:p>
-        </p:txBody>
-      </p:sp>
-      <p:sp>
-        <p:nvSpPr>
-          <p:cNvPr id="16" name="Text 13"/>
-          <p:cNvSpPr txBox="1"/>
-          <p:nvPr/>
-        </p:nvSpPr>
-        <p:spPr>
-          <a:xfrm>
-            <a:off x="800100" y="3852863"/>
-            <a:ext cx="2705100" cy="372904"/>
-          </a:xfrm>
-          <a:prstGeom prst="rect">
-            <a:avLst/>
-          </a:prstGeom>
-          <a:noFill/>
-          <a:ln/>
-        </p:spPr>
-        <p:txBody>
-          <a:bodyPr wrap="square" lIns="0" tIns="0" rIns="0" bIns="0" rtlCol="0" anchor="t"/>
-          <a:lstStyle/>
-          <a:p>
-            <a:pPr algn="l" indent="0" marL="0">
-              <a:buNone/>
-            </a:pPr>
-            <a:r>
-              <a:rPr lang="en-US" sz="1700" b="1" dirty="0">
-                <a:solidFill>
-                  <a:srgbClr val="14140E"/>
-                </a:solidFill>
-                <a:latin typeface="Times New Roman" pitchFamily="34" charset="0"/>
-                <a:ea typeface="Times New Roman" pitchFamily="34" charset="-122"/>
-                <a:cs typeface="Times New Roman" pitchFamily="34" charset="-120"/>
-              </a:rPr>
-              <a:t>Bulk compromise</a:t>
-            </a:r>
-            <a:endParaRPr lang="en-US" sz="1700" dirty="0"/>
-          </a:p>
-        </p:txBody>
-      </p:sp>
-      <p:sp>
-        <p:nvSpPr>
-          <p:cNvPr id="17" name="Text 14"/>
-          <p:cNvSpPr txBox="1"/>
-          <p:nvPr/>
-        </p:nvSpPr>
-        <p:spPr>
-          <a:xfrm>
-            <a:off x="3657600" y="3871913"/>
-            <a:ext cx="4686300" cy="372904"/>
-          </a:xfrm>
-          <a:prstGeom prst="rect">
-            <a:avLst/>
-          </a:prstGeom>
-          <a:noFill/>
-          <a:ln/>
-        </p:spPr>
-        <p:txBody>
-          <a:bodyPr wrap="square" lIns="0" tIns="0" rIns="0" bIns="0" rtlCol="0" anchor="t"/>
-          <a:lstStyle/>
-          <a:p>
-            <a:pPr algn="l" indent="0" marL="0">
-              <a:buNone/>
-            </a:pPr>
-            <a:r>
-              <a:rPr lang="en-US" sz="1700" dirty="0">
-                <a:solidFill>
-                  <a:srgbClr val="6E6E63"/>
-                </a:solidFill>
-                <a:latin typeface="Times New Roman" pitchFamily="34" charset="0"/>
-                <a:ea typeface="Times New Roman" pitchFamily="34" charset="-122"/>
-                <a:cs typeface="Times New Roman" pitchFamily="34" charset="-120"/>
-              </a:rPr>
-              <a:t>single edits are caught, a full rewrite is not</a:t>
-            </a:r>
-            <a:endParaRPr lang="en-US" sz="1700" dirty="0"/>
-          </a:p>
-        </p:txBody>
-      </p:sp>
-    </p:spTree>
-  </p:cSld>
-  <p:clrMapOvr>
-    <a:masterClrMapping/>
-  </p:clrMapOvr>
-</p:sld>
-</file>
-
-<file path=ppt/slides/slide13.xml><?xml version="1.0" encoding="utf-8"?>
-<p:sld xmlns:a="http://schemas.openxmlformats.org/drawingml/2006/main" xmlns:r="http://schemas.openxmlformats.org/officeDocument/2006/relationships" xmlns:p="http://schemas.openxmlformats.org/presentationml/2006/main">
-  <p:cSld name="Slide 13">
-    <p:bg>
-      <p:bgPr>
-        <a:solidFill>
-          <a:srgbClr val="FCFCF9"/>
-        </a:solidFill>
-      </p:bgPr>
-    </p:bg>
-    <p:spTree>
-      <p:nvGrpSpPr>
-        <p:cNvPr id="1" name=""/>
-        <p:cNvGrpSpPr/>
-        <p:nvPr/>
-      </p:nvGrpSpPr>
-      <p:grpSpPr>
-        <a:xfrm>
-          <a:off x="0" y="0"/>
-          <a:ext cx="0" cy="0"/>
-          <a:chOff x="0" y="0"/>
-          <a:chExt cx="0" cy="0"/>
-        </a:xfrm>
-      </p:grpSpPr>
-      <p:sp>
-        <p:nvSpPr>
-          <p:cNvPr id="3" name="Text 0"/>
-          <p:cNvSpPr txBox="1"/>
-          <p:nvPr/>
-        </p:nvSpPr>
-        <p:spPr>
-          <a:xfrm>
-            <a:off x="800100" y="571500"/>
-            <a:ext cx="7543800" cy="205740"/>
-          </a:xfrm>
-          <a:prstGeom prst="rect">
-            <a:avLst/>
-          </a:prstGeom>
-          <a:noFill/>
-          <a:ln/>
-        </p:spPr>
-        <p:txBody>
-          <a:bodyPr wrap="square" lIns="0" tIns="0" rIns="0" bIns="0" rtlCol="0" anchor="t"/>
-          <a:lstStyle/>
-          <a:p>
-            <a:pPr algn="l" indent="0" marL="0">
-              <a:buNone/>
-            </a:pPr>
-            <a:r>
-              <a:rPr lang="en-US" sz="1150" spc="110" kern="0" dirty="0">
-                <a:solidFill>
-                  <a:srgbClr val="6E6E63"/>
-                </a:solidFill>
-                <a:latin typeface="Times New Roman" pitchFamily="34" charset="0"/>
-                <a:ea typeface="Times New Roman" pitchFamily="34" charset="-122"/>
-                <a:cs typeface="Times New Roman" pitchFamily="34" charset="-120"/>
-              </a:rPr>
-              <a:t>If asked</a:t>
-            </a:r>
-            <a:endParaRPr lang="en-US" sz="1150" dirty="0"/>
-          </a:p>
-        </p:txBody>
-      </p:sp>
-      <p:sp>
-        <p:nvSpPr>
-          <p:cNvPr id="4" name="Text 1"/>
-          <p:cNvSpPr txBox="1"/>
-          <p:nvPr/>
-        </p:nvSpPr>
-        <p:spPr>
-          <a:xfrm>
-            <a:off x="7962900" y="4648200"/>
-            <a:ext cx="381000" cy="171450"/>
-          </a:xfrm>
-          <a:prstGeom prst="rect">
-            <a:avLst/>
-          </a:prstGeom>
-          <a:noFill/>
-          <a:ln/>
-        </p:spPr>
-        <p:txBody>
-          <a:bodyPr wrap="square" lIns="0" tIns="0" rIns="0" bIns="0" rtlCol="0" anchor="t"/>
-          <a:lstStyle/>
-          <a:p>
-            <a:pPr algn="r" indent="0" marL="0">
-              <a:buNone/>
-            </a:pPr>
-            <a:r>
-              <a:rPr lang="en-US" sz="1050" dirty="0">
-                <a:solidFill>
-                  <a:srgbClr val="9A9A90"/>
-                </a:solidFill>
-                <a:latin typeface="Times New Roman" pitchFamily="34" charset="0"/>
-                <a:ea typeface="Times New Roman" pitchFamily="34" charset="-122"/>
-                <a:cs typeface="Times New Roman" pitchFamily="34" charset="-120"/>
-              </a:rPr>
-              <a:t>13</a:t>
             </a:r>
             <a:endParaRPr lang="en-US" sz="1050" dirty="0"/>
           </a:p>

</xml_diff>